<commit_message>
Update presentation content for Loom video on selling accounting services. Revised questions for clarity and engagement, ensuring consistent use of interrogative format. Updated section labels and improved overall readability. Modified binary presentation file to reflect these changes.
</commit_message>
<xml_diff>
--- a/presentation/loom-video-vender-a-contadores/Konecta-Loom-Vender-a-Contadores-Final.pptx
+++ b/presentation/loom-video-vender-a-contadores/Konecta-Loom-Vender-a-Contadores-Final.pptx
@@ -694,7 +694,7 @@
           <a:p>
             <a:r>
               <a:rPr lang="en-US" dirty="0"/>
-              <a:t>Llegamos al punto clave. Cuánto cuesta esto?</a:t>
+              <a:t>Llegamos al punto clave. ¿Cuánto cuesta esto?</a:t>
             </a:r>
             <a:endParaRPr lang="en-US" dirty="0"/>
           </a:p>
@@ -870,7 +870,7 @@
           <a:p>
             <a:r>
               <a:rPr lang="en-US" dirty="0"/>
-              <a:t>Si todo hasta aquí te cierra, la siguiente pregunta lógica es: cómo empezamos a trabajar?</a:t>
+              <a:t>Si todo hasta aquí te cierra, la siguiente pregunta lógica es: ¿cómo empezamos a trabajar?</a:t>
             </a:r>
             <a:endParaRPr lang="en-US" dirty="0"/>
           </a:p>
@@ -1046,7 +1046,7 @@
           <a:p>
             <a:r>
               <a:rPr lang="en-US" dirty="0"/>
-              <a:t>Y para cerrar: qué tienes que hacer ahora?</a:t>
+              <a:t>Y para cerrar: ¿qué tienes que hacer ahora?</a:t>
             </a:r>
             <a:endParaRPr lang="en-US" dirty="0"/>
           </a:p>
@@ -1574,7 +1574,7 @@
           <a:p>
             <a:r>
               <a:rPr lang="en-US" dirty="0"/>
-              <a:t>Antes de seguir, una pregunta clave: a quién le sirve esto?</a:t>
+              <a:t>Antes de seguir, una pregunta clave: ¿cómo saber si esto es para ti?</a:t>
             </a:r>
             <a:endParaRPr lang="en-US" dirty="0"/>
           </a:p>
@@ -1750,7 +1750,7 @@
           <a:p>
             <a:r>
               <a:rPr lang="en-US" dirty="0"/>
-              <a:t>Bien. Ahora, cómo lo hacemos?</a:t>
+              <a:t>Bien. Ahora, ¿cómo lo hacemos?</a:t>
             </a:r>
             <a:endParaRPr lang="en-US" dirty="0"/>
           </a:p>

</xml_diff>